<commit_message>
fix(delivery): replace GitHub Classroom with Orbund & GitHub Org, and fix repo/docker inconsistencies
</commit_message>
<xml_diff>
--- a/neo_ML/slides/week1/Week_1_Class_1_Course_Introduction_and_Overview.pptx
+++ b/neo_ML/slides/week1/Week_1_Class_1_Course_Introduction_and_Overview.pptx
@@ -3633,7 +3633,7 @@
               </a:defRPr>
             </a:pPr>
             <a:r>
-              <a:t>CI / CD</a:t>
+              <a:t>PLATFORMS</a:t>
             </a:r>
           </a:p>
           <a:p>
@@ -3649,23 +3649,23 @@
               </a:defRPr>
             </a:pPr>
             <a:r>
-              <a:t>GitHub Classroom</a:t>
-            </a:r>
-          </a:p>
-          <a:p>
-            <a:pPr>
-              <a:spcAft>
-                <a:spcPts val="600"/>
-              </a:spcAft>
-              <a:defRPr sz="1200">
-                <a:solidFill>
-                  <a:srgbClr val="F8FAFC"/>
-                </a:solidFill>
-                <a:latin typeface="Helvetica"/>
-              </a:defRPr>
-            </a:pPr>
-            <a:r>
-              <a:t>•  Personal repo for every student.</a:t>
+              <a:t>GitHub Org &amp; Orbund</a:t>
+            </a:r>
+          </a:p>
+          <a:p>
+            <a:pPr>
+              <a:spcAft>
+                <a:spcPts val="600"/>
+              </a:spcAft>
+              <a:defRPr sz="1200">
+                <a:solidFill>
+                  <a:srgbClr val="F8FAFC"/>
+                </a:solidFill>
+                <a:latin typeface="Helvetica"/>
+              </a:defRPr>
+            </a:pPr>
+            <a:r>
+              <a:t>•  Personal repo in course GitHub Organization.</a:t>
             </a:r>
           </a:p>
           <a:p>
@@ -3697,23 +3697,23 @@
               </a:defRPr>
             </a:pPr>
             <a:r>
-              <a:t>•  Checks code execution &amp; cell outputs.</a:t>
-            </a:r>
-          </a:p>
-          <a:p>
-            <a:pPr>
-              <a:spcAft>
-                <a:spcPts val="600"/>
-              </a:spcAft>
-              <a:defRPr sz="1200">
-                <a:solidFill>
-                  <a:srgbClr val="F8FAFC"/>
-                </a:solidFill>
-                <a:latin typeface="Helvetica"/>
-              </a:defRPr>
-            </a:pPr>
-            <a:r>
-              <a:t>•  Commit log is your portfolio.</a:t>
+              <a:t>•  Official assignments &amp; grading on Orbund.</a:t>
+            </a:r>
+          </a:p>
+          <a:p>
+            <a:pPr>
+              <a:spcAft>
+                <a:spcPts val="600"/>
+              </a:spcAft>
+              <a:defRPr sz="1200">
+                <a:solidFill>
+                  <a:srgbClr val="F8FAFC"/>
+                </a:solidFill>
+                <a:latin typeface="Helvetica"/>
+              </a:defRPr>
+            </a:pPr>
+            <a:r>
+              <a:t>•  Commit log is your authentic portfolio.</a:t>
             </a:r>
           </a:p>
         </p:txBody>
@@ -5051,23 +5051,39 @@
               </a:defRPr>
             </a:pPr>
             <a:r>
-              <a:t>1. GitHub Account</a:t>
-            </a:r>
-          </a:p>
-          <a:p>
-            <a:pPr>
-              <a:spcAft>
-                <a:spcPts val="600"/>
-              </a:spcAft>
-              <a:defRPr sz="1200">
-                <a:solidFill>
-                  <a:srgbClr val="F8FAFC"/>
-                </a:solidFill>
-                <a:latin typeface="Helvetica"/>
-              </a:defRPr>
-            </a:pPr>
-            <a:r>
-              <a:t>•  Join GitHub Classroom via invite link.</a:t>
+              <a:t>1. GitHub Org &amp; Orbund</a:t>
+            </a:r>
+          </a:p>
+          <a:p>
+            <a:pPr>
+              <a:spcAft>
+                <a:spcPts val="600"/>
+              </a:spcAft>
+              <a:defRPr sz="1200">
+                <a:solidFill>
+                  <a:srgbClr val="F8FAFC"/>
+                </a:solidFill>
+                <a:latin typeface="Helvetica"/>
+              </a:defRPr>
+            </a:pPr>
+            <a:r>
+              <a:t>•  Join Course GitHub Org via invite link.</a:t>
+            </a:r>
+          </a:p>
+          <a:p>
+            <a:pPr>
+              <a:spcAft>
+                <a:spcPts val="600"/>
+              </a:spcAft>
+              <a:defRPr sz="1200">
+                <a:solidFill>
+                  <a:srgbClr val="F8FAFC"/>
+                </a:solidFill>
+                <a:latin typeface="Helvetica"/>
+              </a:defRPr>
+            </a:pPr>
+            <a:r>
+              <a:t>•  Verify your Orbund course registration.</a:t>
             </a:r>
           </a:p>
           <a:p>
@@ -5100,22 +5116,6 @@
             </a:pPr>
             <a:r>
               <a:t>•  Activate free GitHub Copilot.</a:t>
-            </a:r>
-          </a:p>
-          <a:p>
-            <a:pPr>
-              <a:spcAft>
-                <a:spcPts val="600"/>
-              </a:spcAft>
-              <a:defRPr sz="1200">
-                <a:solidFill>
-                  <a:srgbClr val="F8FAFC"/>
-                </a:solidFill>
-                <a:latin typeface="Helvetica"/>
-              </a:defRPr>
-            </a:pPr>
-            <a:r>
-              <a:t>•  Link your student email address.</a:t>
             </a:r>
           </a:p>
         </p:txBody>
@@ -5250,7 +5250,7 @@
               </a:defRPr>
             </a:pPr>
             <a:r>
-              <a:t>•  docker pull ghcr.io/lbu-courses/ml-course:week1</a:t>
+              <a:t>•  docker pull ghcr.io/sudan23/ml:week1</a:t>
             </a:r>
           </a:p>
           <a:p>
@@ -5831,7 +5831,7 @@
               </a:defRPr>
             </a:pPr>
             <a:r>
-              <a:t>•  Questions on Docker or GitHub Classroom workflow?</a:t>
+              <a:t>•  Questions on Docker, GitHub Org, or Orbund?</a:t>
             </a:r>
           </a:p>
           <a:p>
@@ -7464,7 +7464,7 @@
               </a:defRPr>
             </a:pPr>
             <a:r>
-              <a:t>•  GitHub Classroom push &amp; validation.</a:t>
+              <a:t>•  GitHub Org push &amp; Orbund submission.</a:t>
             </a:r>
           </a:p>
         </p:txBody>

</xml_diff>

<commit_message>
fix(spec): align with approved UWE module spec (Level 5, 100% individual project, software + 6-page report)
</commit_message>
<xml_diff>
--- a/neo_ML/slides/week1/Week_1_Class_1_Course_Introduction_and_Overview.pptx
+++ b/neo_ML/slides/week1/Week_1_Class_1_Course_Introduction_and_Overview.pptx
@@ -3263,11 +3263,11 @@
               </a:defRPr>
             </a:pPr>
             <a:r>
+              <a:t>Module: UFCFAS-15-2 · Level 5 (15 UK Credits / 7.5 ECTS)</a:t>
+            </a:r>
+            <a:br/>
+            <a:r>
               <a:t>Lecturer: Sudan Pudasaini · Module Leader (UWE): Prof. Jun Hong</a:t>
-            </a:r>
-            <a:br/>
-            <a:r>
-              <a:t>Welcome, Expectations, Roadmap &amp; Modern Delivery Architecture</a:t>
             </a:r>
           </a:p>
         </p:txBody>
@@ -4278,23 +4278,23 @@
               </a:defRPr>
             </a:pPr>
             <a:r>
-              <a:t>•  Having AI write your individual assignment report.</a:t>
-            </a:r>
-          </a:p>
-          <a:p>
-            <a:pPr>
-              <a:spcAft>
-                <a:spcPts val="600"/>
-              </a:spcAft>
-              <a:defRPr sz="1200">
-                <a:solidFill>
-                  <a:srgbClr val="F8FAFC"/>
-                </a:solidFill>
-                <a:latin typeface="Helvetica"/>
-              </a:defRPr>
-            </a:pPr>
-            <a:r>
-              <a:t>•  Generating group project proposals via generative AI.</a:t>
+              <a:t>•  Having AI write your 6-page project report.</a:t>
+            </a:r>
+          </a:p>
+          <a:p>
+            <a:pPr>
+              <a:spcAft>
+                <a:spcPts val="600"/>
+              </a:spcAft>
+              <a:defRPr sz="1200">
+                <a:solidFill>
+                  <a:srgbClr val="F8FAFC"/>
+                </a:solidFill>
+                <a:latin typeface="Helvetica"/>
+              </a:defRPr>
+            </a:pPr>
+            <a:r>
+              <a:t>•  Generating project analysis via generative AI.</a:t>
             </a:r>
           </a:p>
           <a:p>
@@ -5385,7 +5385,7 @@
               </a:defRPr>
             </a:pPr>
             <a:r>
-              <a:t>•  Form initial connections with prospective group peers.</a:t>
+              <a:t>•  Start brainstorming potential project domains.</a:t>
             </a:r>
           </a:p>
           <a:p>
@@ -5847,7 +5847,7 @@
               </a:defRPr>
             </a:pPr>
             <a:r>
-              <a:t>•  Questions on assessment criteria or group allocations?</a:t>
+              <a:t>•  Questions on assessment criteria or the 6-page report?</a:t>
             </a:r>
           </a:p>
           <a:p>
@@ -6277,7 +6277,7 @@
               </a:defRPr>
             </a:pPr>
             <a:r>
-              <a:t>The Level 6 Mindset</a:t>
+              <a:t>The Level 5 Mindset</a:t>
             </a:r>
           </a:p>
           <a:p>
@@ -6652,23 +6652,23 @@
               </a:defRPr>
             </a:pPr>
             <a:r>
-              <a:t>•  Module Code: UFCFAS-15-2 (15 UK Credits).</a:t>
-            </a:r>
-          </a:p>
-          <a:p>
-            <a:pPr>
-              <a:spcAft>
-                <a:spcPts val="600"/>
-              </a:spcAft>
-              <a:defRPr sz="1200">
-                <a:solidFill>
-                  <a:srgbClr val="F8FAFC"/>
-                </a:solidFill>
-                <a:latin typeface="Helvetica"/>
-              </a:defRPr>
-            </a:pPr>
-            <a:r>
-              <a:t>•  Level: Level 6 (Final Year Computing).</a:t>
+              <a:t>•  Module Code: UFCFAS-15-2 (15 UK Credits / 7.5 ECTS).</a:t>
+            </a:r>
+          </a:p>
+          <a:p>
+            <a:pPr>
+              <a:spcAft>
+                <a:spcPts val="600"/>
+              </a:spcAft>
+              <a:defRPr sz="1200">
+                <a:solidFill>
+                  <a:srgbClr val="F8FAFC"/>
+                </a:solidFill>
+                <a:latin typeface="Helvetica"/>
+              </a:defRPr>
+            </a:pPr>
+            <a:r>
+              <a:t>•  Level: Level 5 (Year 2 Computing).</a:t>
             </a:r>
           </a:p>
           <a:p>
@@ -8178,7 +8178,7 @@
               </a:defRPr>
             </a:pPr>
             <a:r>
-              <a:t>University Expectations (Level 6 Academic Rigor)</a:t>
+              <a:t>University Expectations (Level 5 Academic Rigor)</a:t>
             </a:r>
           </a:p>
         </p:txBody>
@@ -8308,7 +8308,7 @@
               </a:defRPr>
             </a:pPr>
             <a:r>
-              <a:t>•  You are the architect of your models and experiments.</a:t>
+              <a:t>•  You are the author and architect of your models and experiments.</a:t>
             </a:r>
           </a:p>
           <a:p>
@@ -8491,7 +8491,7 @@
               </a:defRPr>
             </a:pPr>
             <a:r>
-              <a:t>•  Compare performance against a trivial baseline model.</a:t>
+              <a:t>•  Compare performance against a baseline model.</a:t>
             </a:r>
           </a:p>
           <a:p>
@@ -8937,7 +8937,7 @@
               </a:defRPr>
             </a:pPr>
             <a:r>
-              <a:t>Commit Cadence &amp; Team Ethics</a:t>
+              <a:t>Commit Cadence &amp; Individual Work</a:t>
             </a:r>
           </a:p>
           <a:p>
@@ -8985,55 +8985,55 @@
               </a:defRPr>
             </a:pPr>
             <a:r>
-              <a:t>•  4. Zero Team Ghosting:</a:t>
-            </a:r>
-          </a:p>
-          <a:p>
-            <a:pPr>
-              <a:spcAft>
-                <a:spcPts val="600"/>
-              </a:spcAft>
-              <a:defRPr sz="1200">
-                <a:solidFill>
-                  <a:srgbClr val="F8FAFC"/>
-                </a:solidFill>
-                <a:latin typeface="Helvetica"/>
-              </a:defRPr>
-            </a:pPr>
-            <a:r>
-              <a:t>•  Group project scores are weighted by individual Git commit blame.</a:t>
-            </a:r>
-          </a:p>
-          <a:p>
-            <a:pPr>
-              <a:spcAft>
-                <a:spcPts val="600"/>
-              </a:spcAft>
-              <a:defRPr sz="1200">
-                <a:solidFill>
-                  <a:srgbClr val="F8FAFC"/>
-                </a:solidFill>
-                <a:latin typeface="Helvetica"/>
-              </a:defRPr>
-            </a:pPr>
-            <a:r>
-              <a:t>•  No commits = No individual contribution mark.</a:t>
-            </a:r>
-          </a:p>
-          <a:p>
-            <a:pPr>
-              <a:spcAft>
-                <a:spcPts val="600"/>
-              </a:spcAft>
-              <a:defRPr sz="1200">
-                <a:solidFill>
-                  <a:srgbClr val="F8FAFC"/>
-                </a:solidFill>
-                <a:latin typeface="Helvetica"/>
-              </a:defRPr>
-            </a:pPr>
-            <a:r>
-              <a:t>•  Respect your peers and communicate early.</a:t>
+              <a:t>•  4. Individual Authorship (No Free-Riders):</a:t>
+            </a:r>
+          </a:p>
+          <a:p>
+            <a:pPr>
+              <a:spcAft>
+                <a:spcPts val="600"/>
+              </a:spcAft>
+              <a:defRPr sz="1200">
+                <a:solidFill>
+                  <a:srgbClr val="F8FAFC"/>
+                </a:solidFill>
+                <a:latin typeface="Helvetica"/>
+              </a:defRPr>
+            </a:pPr>
+            <a:r>
+              <a:t>•  This is a 100% individual module (Group Work: No).</a:t>
+            </a:r>
+          </a:p>
+          <a:p>
+            <a:pPr>
+              <a:spcAft>
+                <a:spcPts val="600"/>
+              </a:spcAft>
+              <a:defRPr sz="1200">
+                <a:solidFill>
+                  <a:srgbClr val="F8FAFC"/>
+                </a:solidFill>
+                <a:latin typeface="Helvetica"/>
+              </a:defRPr>
+            </a:pPr>
+            <a:r>
+              <a:t>•  Code authorship is tracked via Git commit history.</a:t>
+            </a:r>
+          </a:p>
+          <a:p>
+            <a:pPr>
+              <a:spcAft>
+                <a:spcPts val="600"/>
+              </a:spcAft>
+              <a:defRPr sz="1200">
+                <a:solidFill>
+                  <a:srgbClr val="F8FAFC"/>
+                </a:solidFill>
+                <a:latin typeface="Helvetica"/>
+              </a:defRPr>
+            </a:pPr>
+            <a:r>
+              <a:t>•  All software and written analysis must be your own.</a:t>
             </a:r>
           </a:p>
         </p:txBody>
@@ -9479,7 +9479,7 @@
               </a:defRPr>
             </a:pPr>
             <a:r>
-              <a:t>•  Milestone: Group Project Proposal Due (10%).</a:t>
+              <a:t>•  Focus: Realities of handling data &amp; imbalanced sets.</a:t>
             </a:r>
           </a:p>
         </p:txBody>
@@ -9598,23 +9598,23 @@
               </a:defRPr>
             </a:pPr>
             <a:r>
-              <a:t>•  Milestone: Individual Assignment Due (30%).</a:t>
-            </a:r>
-          </a:p>
-          <a:p>
-            <a:pPr>
-              <a:spcAft>
-                <a:spcPts val="600"/>
-              </a:spcAft>
-              <a:defRPr sz="1200">
-                <a:solidFill>
-                  <a:srgbClr val="F8FAFC"/>
-                </a:solidFill>
-                <a:latin typeface="Helvetica"/>
-              </a:defRPr>
-            </a:pPr>
-            <a:r>
-              <a:t>•  W10–12: Deep Learning Group Project (60%).</a:t>
+              <a:t>•  W10–12: Deep Learning Implementation &amp; Tuning.</a:t>
+            </a:r>
+          </a:p>
+          <a:p>
+            <a:pPr>
+              <a:spcAft>
+                <a:spcPts val="600"/>
+              </a:spcAft>
+              <a:defRPr sz="1200">
+                <a:solidFill>
+                  <a:srgbClr val="F8FAFC"/>
+                </a:solidFill>
+                <a:latin typeface="Helvetica"/>
+              </a:defRPr>
+            </a:pPr>
+            <a:r>
+              <a:t>•  Final Summative Submission: 100% Individual Project.</a:t>
             </a:r>
           </a:p>
         </p:txBody>
@@ -9747,7 +9747,7 @@
               </a:defRPr>
             </a:pPr>
             <a:r>
-              <a:t>Assessment Structure &amp; Grade Breakdown</a:t>
+              <a:t>Assessment Structure (UWE Approved Specification)</a:t>
             </a:r>
           </a:p>
         </p:txBody>
@@ -9845,7 +9845,7 @@
               </a:defRPr>
             </a:pPr>
             <a:r>
-              <a:t>ASSESSMENT 1</a:t>
+              <a:t>FORMATIVE</a:t>
             </a:r>
           </a:p>
           <a:p>
@@ -9861,71 +9861,71 @@
               </a:defRPr>
             </a:pPr>
             <a:r>
-              <a:t>Group Proposal (10%)</a:t>
-            </a:r>
-          </a:p>
-          <a:p>
-            <a:pPr>
-              <a:spcAft>
-                <a:spcPts val="600"/>
-              </a:spcAft>
-              <a:defRPr sz="1200">
-                <a:solidFill>
-                  <a:srgbClr val="F8FAFC"/>
-                </a:solidFill>
-                <a:latin typeface="Helvetica"/>
-              </a:defRPr>
-            </a:pPr>
-            <a:r>
-              <a:t>•  Due: Week 7 in lab.</a:t>
-            </a:r>
-          </a:p>
-          <a:p>
-            <a:pPr>
-              <a:spcAft>
-                <a:spcPts val="600"/>
-              </a:spcAft>
-              <a:defRPr sz="1200">
-                <a:solidFill>
-                  <a:srgbClr val="F8FAFC"/>
-                </a:solidFill>
-                <a:latin typeface="Helvetica"/>
-              </a:defRPr>
-            </a:pPr>
-            <a:r>
-              <a:t>•  Form teams of 3–4 members.</a:t>
-            </a:r>
-          </a:p>
-          <a:p>
-            <a:pPr>
-              <a:spcAft>
-                <a:spcPts val="600"/>
-              </a:spcAft>
-              <a:defRPr sz="1200">
-                <a:solidFill>
-                  <a:srgbClr val="F8FAFC"/>
-                </a:solidFill>
-                <a:latin typeface="Helvetica"/>
-              </a:defRPr>
-            </a:pPr>
-            <a:r>
-              <a:t>•  Define problem statement and real dataset.</a:t>
-            </a:r>
-          </a:p>
-          <a:p>
-            <a:pPr>
-              <a:spcAft>
-                <a:spcPts val="600"/>
-              </a:spcAft>
-              <a:defRPr sz="1200">
-                <a:solidFill>
-                  <a:srgbClr val="F8FAFC"/>
-                </a:solidFill>
-                <a:latin typeface="Helvetica"/>
-              </a:defRPr>
-            </a:pPr>
-            <a:r>
-              <a:t>•  Propose baseline model &amp; deep learning approach.</a:t>
+              <a:t>Formative Labs (0%)</a:t>
+            </a:r>
+          </a:p>
+          <a:p>
+            <a:pPr>
+              <a:spcAft>
+                <a:spcPts val="600"/>
+              </a:spcAft>
+              <a:defRPr sz="1200">
+                <a:solidFill>
+                  <a:srgbClr val="F8FAFC"/>
+                </a:solidFill>
+                <a:latin typeface="Helvetica"/>
+              </a:defRPr>
+            </a:pPr>
+            <a:r>
+              <a:t>•  Weekly in-lab practical exercises.</a:t>
+            </a:r>
+          </a:p>
+          <a:p>
+            <a:pPr>
+              <a:spcAft>
+                <a:spcPts val="600"/>
+              </a:spcAft>
+              <a:defRPr sz="1200">
+                <a:solidFill>
+                  <a:srgbClr val="F8FAFC"/>
+                </a:solidFill>
+                <a:latin typeface="Helvetica"/>
+              </a:defRPr>
+            </a:pPr>
+            <a:r>
+              <a:t>•  One-to-one demonstrations to tutors.</a:t>
+            </a:r>
+          </a:p>
+          <a:p>
+            <a:pPr>
+              <a:spcAft>
+                <a:spcPts val="600"/>
+              </a:spcAft>
+              <a:defRPr sz="1200">
+                <a:solidFill>
+                  <a:srgbClr val="F8FAFC"/>
+                </a:solidFill>
+                <a:latin typeface="Helvetica"/>
+              </a:defRPr>
+            </a:pPr>
+            <a:r>
+              <a:t>•  Provides continuous formative feedback.</a:t>
+            </a:r>
+          </a:p>
+          <a:p>
+            <a:pPr>
+              <a:spcAft>
+                <a:spcPts val="600"/>
+              </a:spcAft>
+              <a:defRPr sz="1200">
+                <a:solidFill>
+                  <a:srgbClr val="F8FAFC"/>
+                </a:solidFill>
+                <a:latin typeface="Helvetica"/>
+              </a:defRPr>
+            </a:pPr>
+            <a:r>
+              <a:t>•  Immediate code review &amp; debugging support.</a:t>
             </a:r>
           </a:p>
         </p:txBody>
@@ -9980,7 +9980,7 @@
               </a:defRPr>
             </a:pPr>
             <a:r>
-              <a:t>ASSESSMENT 2</a:t>
+              <a:t>SUMMATIVE A</a:t>
             </a:r>
           </a:p>
           <a:p>
@@ -9996,71 +9996,71 @@
               </a:defRPr>
             </a:pPr>
             <a:r>
-              <a:t>Individual Assignment (30%)</a:t>
-            </a:r>
-          </a:p>
-          <a:p>
-            <a:pPr>
-              <a:spcAft>
-                <a:spcPts val="600"/>
-              </a:spcAft>
-              <a:defRPr sz="1200">
-                <a:solidFill>
-                  <a:srgbClr val="F8FAFC"/>
-                </a:solidFill>
-                <a:latin typeface="Helvetica"/>
-              </a:defRPr>
-            </a:pPr>
-            <a:r>
-              <a:t>•  Due: Week 9.</a:t>
-            </a:r>
-          </a:p>
-          <a:p>
-            <a:pPr>
-              <a:spcAft>
-                <a:spcPts val="600"/>
-              </a:spcAft>
-              <a:defRPr sz="1200">
-                <a:solidFill>
-                  <a:srgbClr val="F8FAFC"/>
-                </a:solidFill>
-                <a:latin typeface="Helvetica"/>
-              </a:defRPr>
-            </a:pPr>
-            <a:r>
-              <a:t>•  Select 1 dataset, implement 2 distinct ML algorithms.</a:t>
-            </a:r>
-          </a:p>
-          <a:p>
-            <a:pPr>
-              <a:spcAft>
-                <a:spcPts val="600"/>
-              </a:spcAft>
-              <a:defRPr sz="1200">
-                <a:solidFill>
-                  <a:srgbClr val="F8FAFC"/>
-                </a:solidFill>
-                <a:latin typeface="Helvetica"/>
-              </a:defRPr>
-            </a:pPr>
-            <a:r>
-              <a:t>•  Perform data cleaning, validation, tuning.</a:t>
-            </a:r>
-          </a:p>
-          <a:p>
-            <a:pPr>
-              <a:spcAft>
-                <a:spcPts val="600"/>
-              </a:spcAft>
-              <a:defRPr sz="1200">
-                <a:solidFill>
-                  <a:srgbClr val="F8FAFC"/>
-                </a:solidFill>
-                <a:latin typeface="Helvetica"/>
-              </a:defRPr>
-            </a:pPr>
-            <a:r>
-              <a:t>•  Compare performance metrics in a written report.</a:t>
+              <a:t>Software Artifact (Part of 100%)</a:t>
+            </a:r>
+          </a:p>
+          <a:p>
+            <a:pPr>
+              <a:spcAft>
+                <a:spcPts val="600"/>
+              </a:spcAft>
+              <a:defRPr sz="1200">
+                <a:solidFill>
+                  <a:srgbClr val="F8FAFC"/>
+                </a:solidFill>
+                <a:latin typeface="Helvetica"/>
+              </a:defRPr>
+            </a:pPr>
+            <a:r>
+              <a:t>•  Individual ML software production.</a:t>
+            </a:r>
+          </a:p>
+          <a:p>
+            <a:pPr>
+              <a:spcAft>
+                <a:spcPts val="600"/>
+              </a:spcAft>
+              <a:defRPr sz="1200">
+                <a:solidFill>
+                  <a:srgbClr val="F8FAFC"/>
+                </a:solidFill>
+                <a:latin typeface="Helvetica"/>
+              </a:defRPr>
+            </a:pPr>
+            <a:r>
+              <a:t>•  End-to-end real-world problem solution.</a:t>
+            </a:r>
+          </a:p>
+          <a:p>
+            <a:pPr>
+              <a:spcAft>
+                <a:spcPts val="600"/>
+              </a:spcAft>
+              <a:defRPr sz="1200">
+                <a:solidFill>
+                  <a:srgbClr val="F8FAFC"/>
+                </a:solidFill>
+                <a:latin typeface="Helvetica"/>
+              </a:defRPr>
+            </a:pPr>
+            <a:r>
+              <a:t>•  Data preprocessing, training, testing.</a:t>
+            </a:r>
+          </a:p>
+          <a:p>
+            <a:pPr>
+              <a:spcAft>
+                <a:spcPts val="600"/>
+              </a:spcAft>
+              <a:defRPr sz="1200">
+                <a:solidFill>
+                  <a:srgbClr val="F8FAFC"/>
+                </a:solidFill>
+                <a:latin typeface="Helvetica"/>
+              </a:defRPr>
+            </a:pPr>
+            <a:r>
+              <a:t>•  Tests Learning Outcomes: MO1, MO2, MO3.</a:t>
             </a:r>
           </a:p>
         </p:txBody>
@@ -10115,7 +10115,7 @@
               </a:defRPr>
             </a:pPr>
             <a:r>
-              <a:t>ASSESSMENT 3</a:t>
+              <a:t>SUMMATIVE B</a:t>
             </a:r>
           </a:p>
           <a:p>
@@ -10131,71 +10131,87 @@
               </a:defRPr>
             </a:pPr>
             <a:r>
-              <a:t>Group Project (60%)</a:t>
-            </a:r>
-          </a:p>
-          <a:p>
-            <a:pPr>
-              <a:spcAft>
-                <a:spcPts val="600"/>
-              </a:spcAft>
-              <a:defRPr sz="1200">
-                <a:solidFill>
-                  <a:srgbClr val="F8FAFC"/>
-                </a:solidFill>
-                <a:latin typeface="Helvetica"/>
-              </a:defRPr>
-            </a:pPr>
-            <a:r>
-              <a:t>•  Due: Week 12 Final Hand-in.</a:t>
-            </a:r>
-          </a:p>
-          <a:p>
-            <a:pPr>
-              <a:spcAft>
-                <a:spcPts val="600"/>
-              </a:spcAft>
-              <a:defRPr sz="1200">
-                <a:solidFill>
-                  <a:srgbClr val="F8FAFC"/>
-                </a:solidFill>
-                <a:latin typeface="Helvetica"/>
-              </a:defRPr>
-            </a:pPr>
-            <a:r>
-              <a:t>•  End-to-end Deep Learning system (CNN / DNN).</a:t>
-            </a:r>
-          </a:p>
-          <a:p>
-            <a:pPr>
-              <a:spcAft>
-                <a:spcPts val="600"/>
-              </a:spcAft>
-              <a:defRPr sz="1200">
-                <a:solidFill>
-                  <a:srgbClr val="F8FAFC"/>
-                </a:solidFill>
-                <a:latin typeface="Helvetica"/>
-              </a:defRPr>
-            </a:pPr>
-            <a:r>
-              <a:t>•  Live team presentation &amp; code defense.</a:t>
-            </a:r>
-          </a:p>
-          <a:p>
-            <a:pPr>
-              <a:spcAft>
-                <a:spcPts val="600"/>
-              </a:spcAft>
-              <a:defRPr sz="1200">
-                <a:solidFill>
-                  <a:srgbClr val="F8FAFC"/>
-                </a:solidFill>
-                <a:latin typeface="Helvetica"/>
-              </a:defRPr>
-            </a:pPr>
-            <a:r>
-              <a:t>•  Git commit history verifies individual effort!</a:t>
+              <a:t>6-Page Report (Part of 100%)</a:t>
+            </a:r>
+          </a:p>
+          <a:p>
+            <a:pPr>
+              <a:spcAft>
+                <a:spcPts val="600"/>
+              </a:spcAft>
+              <a:defRPr sz="1200">
+                <a:solidFill>
+                  <a:srgbClr val="F8FAFC"/>
+                </a:solidFill>
+                <a:latin typeface="Helvetica"/>
+              </a:defRPr>
+            </a:pPr>
+            <a:r>
+              <a:t>•  Online submission via Orbund.</a:t>
+            </a:r>
+          </a:p>
+          <a:p>
+            <a:pPr>
+              <a:spcAft>
+                <a:spcPts val="600"/>
+              </a:spcAft>
+              <a:defRPr sz="1200">
+                <a:solidFill>
+                  <a:srgbClr val="F8FAFC"/>
+                </a:solidFill>
+                <a:latin typeface="Helvetica"/>
+              </a:defRPr>
+            </a:pPr>
+            <a:r>
+              <a:t>•  Follows official UWE formatting guidelines.</a:t>
+            </a:r>
+          </a:p>
+          <a:p>
+            <a:pPr>
+              <a:spcAft>
+                <a:spcPts val="600"/>
+              </a:spcAft>
+              <a:defRPr sz="1200">
+                <a:solidFill>
+                  <a:srgbClr val="F8FAFC"/>
+                </a:solidFill>
+                <a:latin typeface="Helvetica"/>
+              </a:defRPr>
+            </a:pPr>
+            <a:r>
+              <a:t>•  Problem formulation &amp; algorithm choice.</a:t>
+            </a:r>
+          </a:p>
+          <a:p>
+            <a:pPr>
+              <a:spcAft>
+                <a:spcPts val="600"/>
+              </a:spcAft>
+              <a:defRPr sz="1200">
+                <a:solidFill>
+                  <a:srgbClr val="F8FAFC"/>
+                </a:solidFill>
+                <a:latin typeface="Helvetica"/>
+              </a:defRPr>
+            </a:pPr>
+            <a:r>
+              <a:t>•  Empirical testing, evaluation &amp; ethics.</a:t>
+            </a:r>
+          </a:p>
+          <a:p>
+            <a:pPr>
+              <a:spcAft>
+                <a:spcPts val="600"/>
+              </a:spcAft>
+              <a:defRPr sz="1200">
+                <a:solidFill>
+                  <a:srgbClr val="F8FAFC"/>
+                </a:solidFill>
+                <a:latin typeface="Helvetica"/>
+              </a:defRPr>
+            </a:pPr>
+            <a:r>
+              <a:t>•  Group Work: NO (100% Individual Project).</a:t>
             </a:r>
           </a:p>
         </p:txBody>

</xml_diff>